<commit_message>
chore: update modeling notebook execution results and project presentation slides
</commit_message>
<xml_diff>
--- a/Projet_Neil_Haci/soutenance_churn_v3.pptx
+++ b/Projet_Neil_Haci/soutenance_churn_v3.pptx
@@ -3750,7 +3750,7 @@
               <a:t>risque</a:t>
             </a:r>
             <a:r>
-              <a:rPr lang="en-US" sz="950">
+              <a:rPr lang="en-US" sz="950" dirty="0">
                 <a:solidFill>
                   <a:srgbClr val="94A3B8"/>
                 </a:solidFill>
@@ -3758,18 +3758,7 @@
                 <a:ea typeface="Calibri" pitchFamily="34" charset="-122"/>
                 <a:cs typeface="Calibri" pitchFamily="34" charset="-120"/>
               </a:rPr>
-              <a:t> 7 </a:t>
-            </a:r>
-            <a:r>
-              <a:rPr lang="en-US" sz="950" dirty="0">
-                <a:solidFill>
-                  <a:srgbClr val="94A3B8"/>
-                </a:solidFill>
-                <a:latin typeface="Calibri" pitchFamily="34" charset="0"/>
-                <a:ea typeface="Calibri" pitchFamily="34" charset="-122"/>
-                <a:cs typeface="Calibri" pitchFamily="34" charset="-120"/>
-              </a:rPr>
-              <a:t>€/an</a:t>
+              <a:t> 7 €/an</a:t>
             </a:r>
             <a:endParaRPr lang="en-US" sz="950" dirty="0"/>
           </a:p>
@@ -16699,7 +16688,7 @@
                 <a:ea typeface="Calibri" pitchFamily="34" charset="-122"/>
                 <a:cs typeface="Calibri" pitchFamily="34" charset="-120"/>
               </a:rPr>
-              <a:t>GB : seuil=0,48 (calibration naturelle)  |  RF : seuil=0,14 (surcalibration, signe d'overfitting)</a:t>
+              <a:t>GB : seuil=0,48 (calibration naturelle)  |  RF : seuil=0,19 (surcalibration, signe d'overfitting)</a:t>
             </a:r>
             <a:endParaRPr lang="en-US" sz="950" dirty="0"/>
           </a:p>
@@ -25056,7 +25045,7 @@
               <a:buNone/>
             </a:pPr>
             <a:r>
-              <a:rPr lang="en-US" sz="850" dirty="0">
+              <a:rPr lang="en-US" sz="850" dirty="0" err="1">
                 <a:solidFill>
                   <a:srgbClr val="FFFFFF"/>
                 </a:solidFill>
@@ -25064,7 +25053,7 @@
                 <a:ea typeface="Consolas" pitchFamily="34" charset="-122"/>
                 <a:cs typeface="Consolas" pitchFamily="34" charset="-120"/>
               </a:rPr>
-              <a:t>monthly_logins</a:t>
+              <a:t>csat_score</a:t>
             </a:r>
             <a:endParaRPr lang="en-US" sz="850" dirty="0"/>
           </a:p>

</xml_diff>

<commit_message>
update retrain with 29 features now, fix word
</commit_message>
<xml_diff>
--- a/Projet_Neil_Haci/soutenance_churn_v3.pptx
+++ b/Projet_Neil_Haci/soutenance_churn_v3.pptx
@@ -12593,7 +12593,7 @@
                 <a:ea typeface="Calibri" pitchFamily="34" charset="-122"/>
                 <a:cs typeface="Calibri" pitchFamily="34" charset="-120"/>
               </a:rPr>
-              <a:t>Variables retenues pour la modélisation (11)</a:t>
+              <a:t>Variables retenues pour la modélisation (12)</a:t>
             </a:r>
             <a:endParaRPr lang="en-US" sz="1100" dirty="0"/>
           </a:p>
@@ -19386,7 +19386,7 @@
         </p:nvSpPr>
         <p:spPr>
           <a:xfrm>
-            <a:off x="256032" y="1048911"/>
+            <a:off x="790726" y="1072158"/>
             <a:ext cx="2075688" cy="256032"/>
           </a:xfrm>
           <a:prstGeom prst="rect">
@@ -19413,7 +19413,7 @@
         </p:nvSpPr>
         <p:spPr>
           <a:xfrm>
-            <a:off x="256032" y="1048911"/>
+            <a:off x="790726" y="1072158"/>
             <a:ext cx="2075688" cy="256032"/>
           </a:xfrm>
           <a:prstGeom prst="rect">
@@ -19452,7 +19452,7 @@
         </p:nvSpPr>
         <p:spPr>
           <a:xfrm>
-            <a:off x="2359152" y="1048911"/>
+            <a:off x="2893846" y="1072158"/>
             <a:ext cx="658368" cy="256032"/>
           </a:xfrm>
           <a:prstGeom prst="rect">
@@ -19479,7 +19479,7 @@
         </p:nvSpPr>
         <p:spPr>
           <a:xfrm>
-            <a:off x="2359152" y="1048911"/>
+            <a:off x="2893846" y="1072158"/>
             <a:ext cx="658368" cy="256032"/>
           </a:xfrm>
           <a:prstGeom prst="rect">
@@ -19518,7 +19518,7 @@
         </p:nvSpPr>
         <p:spPr>
           <a:xfrm>
-            <a:off x="3044952" y="1048911"/>
+            <a:off x="3579646" y="1072158"/>
             <a:ext cx="795528" cy="256032"/>
           </a:xfrm>
           <a:prstGeom prst="rect">
@@ -19545,7 +19545,7 @@
         </p:nvSpPr>
         <p:spPr>
           <a:xfrm>
-            <a:off x="3044952" y="1048911"/>
+            <a:off x="3579646" y="1072158"/>
             <a:ext cx="795528" cy="256032"/>
           </a:xfrm>
           <a:prstGeom prst="rect">
@@ -19584,7 +19584,7 @@
         </p:nvSpPr>
         <p:spPr>
           <a:xfrm>
-            <a:off x="3867912" y="1048911"/>
+            <a:off x="4402606" y="1072158"/>
             <a:ext cx="795528" cy="256032"/>
           </a:xfrm>
           <a:prstGeom prst="rect">
@@ -19611,7 +19611,7 @@
         </p:nvSpPr>
         <p:spPr>
           <a:xfrm>
-            <a:off x="3867912" y="1048911"/>
+            <a:off x="4402606" y="1072158"/>
             <a:ext cx="795528" cy="256032"/>
           </a:xfrm>
           <a:prstGeom prst="rect">
@@ -19650,7 +19650,7 @@
         </p:nvSpPr>
         <p:spPr>
           <a:xfrm>
-            <a:off x="4690872" y="1048911"/>
+            <a:off x="5225566" y="1072158"/>
             <a:ext cx="722376" cy="256032"/>
           </a:xfrm>
           <a:prstGeom prst="rect">
@@ -19677,7 +19677,7 @@
         </p:nvSpPr>
         <p:spPr>
           <a:xfrm>
-            <a:off x="4690872" y="1048911"/>
+            <a:off x="5225566" y="1072158"/>
             <a:ext cx="722376" cy="256032"/>
           </a:xfrm>
           <a:prstGeom prst="rect">
@@ -19716,7 +19716,7 @@
         </p:nvSpPr>
         <p:spPr>
           <a:xfrm>
-            <a:off x="5440680" y="1048911"/>
+            <a:off x="5975374" y="1072158"/>
             <a:ext cx="722376" cy="256032"/>
           </a:xfrm>
           <a:prstGeom prst="rect">
@@ -19743,7 +19743,7 @@
         </p:nvSpPr>
         <p:spPr>
           <a:xfrm>
-            <a:off x="5440680" y="1048911"/>
+            <a:off x="5975374" y="1072158"/>
             <a:ext cx="722376" cy="256032"/>
           </a:xfrm>
           <a:prstGeom prst="rect">
@@ -19782,7 +19782,7 @@
         </p:nvSpPr>
         <p:spPr>
           <a:xfrm>
-            <a:off x="6190488" y="1048911"/>
+            <a:off x="6725182" y="1072158"/>
             <a:ext cx="777240" cy="256032"/>
           </a:xfrm>
           <a:prstGeom prst="rect">
@@ -19809,7 +19809,7 @@
         </p:nvSpPr>
         <p:spPr>
           <a:xfrm>
-            <a:off x="6190488" y="1048911"/>
+            <a:off x="6725182" y="1072158"/>
             <a:ext cx="777240" cy="256032"/>
           </a:xfrm>
           <a:prstGeom prst="rect">
@@ -19848,7 +19848,7 @@
         </p:nvSpPr>
         <p:spPr>
           <a:xfrm>
-            <a:off x="6995160" y="1048911"/>
+            <a:off x="7529854" y="1072158"/>
             <a:ext cx="777240" cy="256032"/>
           </a:xfrm>
           <a:prstGeom prst="rect">
@@ -19875,7 +19875,7 @@
         </p:nvSpPr>
         <p:spPr>
           <a:xfrm>
-            <a:off x="6995160" y="1048911"/>
+            <a:off x="7529854" y="1072158"/>
             <a:ext cx="777240" cy="256032"/>
           </a:xfrm>
           <a:prstGeom prst="rect">
@@ -19914,7 +19914,7 @@
         </p:nvSpPr>
         <p:spPr>
           <a:xfrm>
-            <a:off x="256032" y="1341519"/>
+            <a:off x="790726" y="1364766"/>
             <a:ext cx="7397336" cy="274320"/>
           </a:xfrm>
           <a:prstGeom prst="rect">
@@ -19943,7 +19943,7 @@
         </p:nvSpPr>
         <p:spPr>
           <a:xfrm>
-            <a:off x="256032" y="1341519"/>
+            <a:off x="790726" y="1364766"/>
             <a:ext cx="2075688" cy="265176"/>
           </a:xfrm>
           <a:prstGeom prst="rect">
@@ -19970,7 +19970,7 @@
         </p:nvSpPr>
         <p:spPr>
           <a:xfrm>
-            <a:off x="256032" y="1341519"/>
+            <a:off x="790726" y="1364766"/>
             <a:ext cx="2075688" cy="265176"/>
           </a:xfrm>
           <a:prstGeom prst="rect">
@@ -20009,7 +20009,7 @@
         </p:nvSpPr>
         <p:spPr>
           <a:xfrm>
-            <a:off x="2359152" y="1341519"/>
+            <a:off x="2893846" y="1364766"/>
             <a:ext cx="658368" cy="265176"/>
           </a:xfrm>
           <a:prstGeom prst="rect">
@@ -20036,7 +20036,7 @@
         </p:nvSpPr>
         <p:spPr>
           <a:xfrm>
-            <a:off x="2359152" y="1341519"/>
+            <a:off x="2893846" y="1364766"/>
             <a:ext cx="658368" cy="265176"/>
           </a:xfrm>
           <a:prstGeom prst="rect">
@@ -20075,7 +20075,7 @@
         </p:nvSpPr>
         <p:spPr>
           <a:xfrm>
-            <a:off x="3044952" y="1341519"/>
+            <a:off x="3579646" y="1364766"/>
             <a:ext cx="795528" cy="265176"/>
           </a:xfrm>
           <a:prstGeom prst="rect">
@@ -20102,7 +20102,7 @@
         </p:nvSpPr>
         <p:spPr>
           <a:xfrm>
-            <a:off x="3044952" y="1341519"/>
+            <a:off x="3579646" y="1364766"/>
             <a:ext cx="795528" cy="265176"/>
           </a:xfrm>
           <a:prstGeom prst="rect">
@@ -20141,7 +20141,7 @@
         </p:nvSpPr>
         <p:spPr>
           <a:xfrm>
-            <a:off x="3867912" y="1341519"/>
+            <a:off x="4402606" y="1364766"/>
             <a:ext cx="795528" cy="265176"/>
           </a:xfrm>
           <a:prstGeom prst="rect">
@@ -20168,7 +20168,7 @@
         </p:nvSpPr>
         <p:spPr>
           <a:xfrm>
-            <a:off x="3867912" y="1341519"/>
+            <a:off x="4402606" y="1364766"/>
             <a:ext cx="795528" cy="265176"/>
           </a:xfrm>
           <a:prstGeom prst="rect">
@@ -20207,7 +20207,7 @@
         </p:nvSpPr>
         <p:spPr>
           <a:xfrm>
-            <a:off x="4690872" y="1341519"/>
+            <a:off x="5225566" y="1364766"/>
             <a:ext cx="722376" cy="265176"/>
           </a:xfrm>
           <a:prstGeom prst="rect">
@@ -20234,7 +20234,7 @@
         </p:nvSpPr>
         <p:spPr>
           <a:xfrm>
-            <a:off x="4690872" y="1341519"/>
+            <a:off x="5225566" y="1364766"/>
             <a:ext cx="722376" cy="265176"/>
           </a:xfrm>
           <a:prstGeom prst="rect">
@@ -20273,7 +20273,7 @@
         </p:nvSpPr>
         <p:spPr>
           <a:xfrm>
-            <a:off x="5440680" y="1341519"/>
+            <a:off x="5975374" y="1364766"/>
             <a:ext cx="722376" cy="265176"/>
           </a:xfrm>
           <a:prstGeom prst="rect">
@@ -20300,7 +20300,7 @@
         </p:nvSpPr>
         <p:spPr>
           <a:xfrm>
-            <a:off x="5440680" y="1341519"/>
+            <a:off x="5975374" y="1364766"/>
             <a:ext cx="722376" cy="265176"/>
           </a:xfrm>
           <a:prstGeom prst="rect">
@@ -20339,7 +20339,7 @@
         </p:nvSpPr>
         <p:spPr>
           <a:xfrm>
-            <a:off x="6190488" y="1341519"/>
+            <a:off x="6725182" y="1364766"/>
             <a:ext cx="777240" cy="265176"/>
           </a:xfrm>
           <a:prstGeom prst="rect">
@@ -20366,7 +20366,7 @@
         </p:nvSpPr>
         <p:spPr>
           <a:xfrm>
-            <a:off x="6190488" y="1341519"/>
+            <a:off x="6725182" y="1364766"/>
             <a:ext cx="777240" cy="265176"/>
           </a:xfrm>
           <a:prstGeom prst="rect">
@@ -20405,7 +20405,7 @@
         </p:nvSpPr>
         <p:spPr>
           <a:xfrm>
-            <a:off x="6995160" y="1341519"/>
+            <a:off x="7529854" y="1364766"/>
             <a:ext cx="777240" cy="265176"/>
           </a:xfrm>
           <a:prstGeom prst="rect">
@@ -20432,7 +20432,7 @@
         </p:nvSpPr>
         <p:spPr>
           <a:xfrm>
-            <a:off x="6995160" y="1341519"/>
+            <a:off x="7529854" y="1364766"/>
             <a:ext cx="777240" cy="265176"/>
           </a:xfrm>
           <a:prstGeom prst="rect">
@@ -20471,7 +20471,7 @@
         </p:nvSpPr>
         <p:spPr>
           <a:xfrm>
-            <a:off x="256032" y="1615839"/>
+            <a:off x="790726" y="1639086"/>
             <a:ext cx="2075688" cy="265176"/>
           </a:xfrm>
           <a:prstGeom prst="rect">
@@ -20498,7 +20498,7 @@
         </p:nvSpPr>
         <p:spPr>
           <a:xfrm>
-            <a:off x="256032" y="1615839"/>
+            <a:off x="790726" y="1639086"/>
             <a:ext cx="2075688" cy="265176"/>
           </a:xfrm>
           <a:prstGeom prst="rect">
@@ -20537,7 +20537,7 @@
         </p:nvSpPr>
         <p:spPr>
           <a:xfrm>
-            <a:off x="2359152" y="1615839"/>
+            <a:off x="2893846" y="1639086"/>
             <a:ext cx="658368" cy="265176"/>
           </a:xfrm>
           <a:prstGeom prst="rect">
@@ -20564,7 +20564,7 @@
         </p:nvSpPr>
         <p:spPr>
           <a:xfrm>
-            <a:off x="2359152" y="1615839"/>
+            <a:off x="2893846" y="1639086"/>
             <a:ext cx="658368" cy="265176"/>
           </a:xfrm>
           <a:prstGeom prst="rect">
@@ -20603,7 +20603,7 @@
         </p:nvSpPr>
         <p:spPr>
           <a:xfrm>
-            <a:off x="3044952" y="1615839"/>
+            <a:off x="3579646" y="1639086"/>
             <a:ext cx="795528" cy="265176"/>
           </a:xfrm>
           <a:prstGeom prst="rect">
@@ -20630,7 +20630,7 @@
         </p:nvSpPr>
         <p:spPr>
           <a:xfrm>
-            <a:off x="3044952" y="1615839"/>
+            <a:off x="3579646" y="1639086"/>
             <a:ext cx="795528" cy="265176"/>
           </a:xfrm>
           <a:prstGeom prst="rect">
@@ -20669,7 +20669,7 @@
         </p:nvSpPr>
         <p:spPr>
           <a:xfrm>
-            <a:off x="3867912" y="1615839"/>
+            <a:off x="4402606" y="1639086"/>
             <a:ext cx="795528" cy="265176"/>
           </a:xfrm>
           <a:prstGeom prst="rect">
@@ -20696,7 +20696,7 @@
         </p:nvSpPr>
         <p:spPr>
           <a:xfrm>
-            <a:off x="3867912" y="1615839"/>
+            <a:off x="4402606" y="1639086"/>
             <a:ext cx="795528" cy="265176"/>
           </a:xfrm>
           <a:prstGeom prst="rect">
@@ -20735,7 +20735,7 @@
         </p:nvSpPr>
         <p:spPr>
           <a:xfrm>
-            <a:off x="4690872" y="1615839"/>
+            <a:off x="5225566" y="1639086"/>
             <a:ext cx="722376" cy="265176"/>
           </a:xfrm>
           <a:prstGeom prst="rect">
@@ -20762,7 +20762,7 @@
         </p:nvSpPr>
         <p:spPr>
           <a:xfrm>
-            <a:off x="4690872" y="1615839"/>
+            <a:off x="5225566" y="1639086"/>
             <a:ext cx="722376" cy="265176"/>
           </a:xfrm>
           <a:prstGeom prst="rect">
@@ -20801,7 +20801,7 @@
         </p:nvSpPr>
         <p:spPr>
           <a:xfrm>
-            <a:off x="5440680" y="1615839"/>
+            <a:off x="5975374" y="1639086"/>
             <a:ext cx="722376" cy="265176"/>
           </a:xfrm>
           <a:prstGeom prst="rect">
@@ -20828,7 +20828,7 @@
         </p:nvSpPr>
         <p:spPr>
           <a:xfrm>
-            <a:off x="5440680" y="1615839"/>
+            <a:off x="5975374" y="1639086"/>
             <a:ext cx="722376" cy="265176"/>
           </a:xfrm>
           <a:prstGeom prst="rect">
@@ -20867,7 +20867,7 @@
         </p:nvSpPr>
         <p:spPr>
           <a:xfrm>
-            <a:off x="6190488" y="1615839"/>
+            <a:off x="6725182" y="1639086"/>
             <a:ext cx="777240" cy="265176"/>
           </a:xfrm>
           <a:prstGeom prst="rect">
@@ -20894,7 +20894,7 @@
         </p:nvSpPr>
         <p:spPr>
           <a:xfrm>
-            <a:off x="6190488" y="1615839"/>
+            <a:off x="6725182" y="1639086"/>
             <a:ext cx="777240" cy="265176"/>
           </a:xfrm>
           <a:prstGeom prst="rect">
@@ -20933,7 +20933,7 @@
         </p:nvSpPr>
         <p:spPr>
           <a:xfrm>
-            <a:off x="6995160" y="1615839"/>
+            <a:off x="7529854" y="1639086"/>
             <a:ext cx="777240" cy="265176"/>
           </a:xfrm>
           <a:prstGeom prst="rect">
@@ -20960,7 +20960,7 @@
         </p:nvSpPr>
         <p:spPr>
           <a:xfrm>
-            <a:off x="6995160" y="1615839"/>
+            <a:off x="7529854" y="1639086"/>
             <a:ext cx="777240" cy="265176"/>
           </a:xfrm>
           <a:prstGeom prst="rect">
@@ -20999,7 +20999,7 @@
         </p:nvSpPr>
         <p:spPr>
           <a:xfrm>
-            <a:off x="256032" y="1890159"/>
+            <a:off x="790726" y="1913406"/>
             <a:ext cx="2075688" cy="265176"/>
           </a:xfrm>
           <a:prstGeom prst="rect">
@@ -21026,7 +21026,7 @@
         </p:nvSpPr>
         <p:spPr>
           <a:xfrm>
-            <a:off x="256032" y="1890159"/>
+            <a:off x="790726" y="1913406"/>
             <a:ext cx="2075688" cy="265176"/>
           </a:xfrm>
           <a:prstGeom prst="rect">
@@ -21065,7 +21065,7 @@
         </p:nvSpPr>
         <p:spPr>
           <a:xfrm>
-            <a:off x="2359152" y="1890159"/>
+            <a:off x="2893846" y="1913406"/>
             <a:ext cx="658368" cy="265176"/>
           </a:xfrm>
           <a:prstGeom prst="rect">
@@ -21092,7 +21092,7 @@
         </p:nvSpPr>
         <p:spPr>
           <a:xfrm>
-            <a:off x="2359152" y="1890159"/>
+            <a:off x="2893846" y="1913406"/>
             <a:ext cx="658368" cy="265176"/>
           </a:xfrm>
           <a:prstGeom prst="rect">
@@ -21131,7 +21131,7 @@
         </p:nvSpPr>
         <p:spPr>
           <a:xfrm>
-            <a:off x="3044952" y="1890159"/>
+            <a:off x="3579646" y="1913406"/>
             <a:ext cx="795528" cy="265176"/>
           </a:xfrm>
           <a:prstGeom prst="rect">
@@ -21158,7 +21158,7 @@
         </p:nvSpPr>
         <p:spPr>
           <a:xfrm>
-            <a:off x="3044952" y="1890159"/>
+            <a:off x="3579646" y="1913406"/>
             <a:ext cx="795528" cy="265176"/>
           </a:xfrm>
           <a:prstGeom prst="rect">
@@ -21197,7 +21197,7 @@
         </p:nvSpPr>
         <p:spPr>
           <a:xfrm>
-            <a:off x="3867912" y="1890159"/>
+            <a:off x="4402606" y="1913406"/>
             <a:ext cx="795528" cy="265176"/>
           </a:xfrm>
           <a:prstGeom prst="rect">
@@ -21224,7 +21224,7 @@
         </p:nvSpPr>
         <p:spPr>
           <a:xfrm>
-            <a:off x="3867912" y="1890159"/>
+            <a:off x="4402606" y="1913406"/>
             <a:ext cx="795528" cy="265176"/>
           </a:xfrm>
           <a:prstGeom prst="rect">
@@ -21263,7 +21263,7 @@
         </p:nvSpPr>
         <p:spPr>
           <a:xfrm>
-            <a:off x="4690872" y="1890159"/>
+            <a:off x="5225566" y="1913406"/>
             <a:ext cx="722376" cy="265176"/>
           </a:xfrm>
           <a:prstGeom prst="rect">
@@ -21290,7 +21290,7 @@
         </p:nvSpPr>
         <p:spPr>
           <a:xfrm>
-            <a:off x="4690872" y="1890159"/>
+            <a:off x="5225566" y="1913406"/>
             <a:ext cx="722376" cy="265176"/>
           </a:xfrm>
           <a:prstGeom prst="rect">
@@ -21329,7 +21329,7 @@
         </p:nvSpPr>
         <p:spPr>
           <a:xfrm>
-            <a:off x="5440680" y="1890159"/>
+            <a:off x="5975374" y="1913406"/>
             <a:ext cx="722376" cy="265176"/>
           </a:xfrm>
           <a:prstGeom prst="rect">
@@ -21356,7 +21356,7 @@
         </p:nvSpPr>
         <p:spPr>
           <a:xfrm>
-            <a:off x="5440680" y="1890159"/>
+            <a:off x="5975374" y="1913406"/>
             <a:ext cx="722376" cy="265176"/>
           </a:xfrm>
           <a:prstGeom prst="rect">
@@ -21395,7 +21395,7 @@
         </p:nvSpPr>
         <p:spPr>
           <a:xfrm>
-            <a:off x="6190488" y="1890159"/>
+            <a:off x="6725182" y="1913406"/>
             <a:ext cx="777240" cy="265176"/>
           </a:xfrm>
           <a:prstGeom prst="rect">
@@ -21422,7 +21422,7 @@
         </p:nvSpPr>
         <p:spPr>
           <a:xfrm>
-            <a:off x="6190488" y="1890159"/>
+            <a:off x="6725182" y="1913406"/>
             <a:ext cx="777240" cy="265176"/>
           </a:xfrm>
           <a:prstGeom prst="rect">
@@ -21461,7 +21461,7 @@
         </p:nvSpPr>
         <p:spPr>
           <a:xfrm>
-            <a:off x="6995160" y="1890159"/>
+            <a:off x="7529854" y="1913406"/>
             <a:ext cx="777240" cy="265176"/>
           </a:xfrm>
           <a:prstGeom prst="rect">
@@ -21488,7 +21488,7 @@
         </p:nvSpPr>
         <p:spPr>
           <a:xfrm>
-            <a:off x="6995160" y="1890159"/>
+            <a:off x="7529854" y="1913406"/>
             <a:ext cx="777240" cy="265176"/>
           </a:xfrm>
           <a:prstGeom prst="rect">
@@ -21527,7 +21527,7 @@
         </p:nvSpPr>
         <p:spPr>
           <a:xfrm>
-            <a:off x="256032" y="2164479"/>
+            <a:off x="790726" y="2187726"/>
             <a:ext cx="2075688" cy="265176"/>
           </a:xfrm>
           <a:prstGeom prst="rect">
@@ -21554,7 +21554,7 @@
         </p:nvSpPr>
         <p:spPr>
           <a:xfrm>
-            <a:off x="256032" y="2164479"/>
+            <a:off x="790726" y="2187726"/>
             <a:ext cx="2075688" cy="265176"/>
           </a:xfrm>
           <a:prstGeom prst="rect">
@@ -21593,7 +21593,7 @@
         </p:nvSpPr>
         <p:spPr>
           <a:xfrm>
-            <a:off x="2359152" y="2164479"/>
+            <a:off x="2893846" y="2187726"/>
             <a:ext cx="658368" cy="265176"/>
           </a:xfrm>
           <a:prstGeom prst="rect">
@@ -21620,7 +21620,7 @@
         </p:nvSpPr>
         <p:spPr>
           <a:xfrm>
-            <a:off x="2359152" y="2164479"/>
+            <a:off x="2893846" y="2187726"/>
             <a:ext cx="658368" cy="265176"/>
           </a:xfrm>
           <a:prstGeom prst="rect">
@@ -21659,7 +21659,7 @@
         </p:nvSpPr>
         <p:spPr>
           <a:xfrm>
-            <a:off x="3044952" y="2164479"/>
+            <a:off x="3579646" y="2187726"/>
             <a:ext cx="795528" cy="265176"/>
           </a:xfrm>
           <a:prstGeom prst="rect">
@@ -21686,7 +21686,7 @@
         </p:nvSpPr>
         <p:spPr>
           <a:xfrm>
-            <a:off x="3044952" y="2164479"/>
+            <a:off x="3579646" y="2187726"/>
             <a:ext cx="795528" cy="265176"/>
           </a:xfrm>
           <a:prstGeom prst="rect">
@@ -21725,7 +21725,7 @@
         </p:nvSpPr>
         <p:spPr>
           <a:xfrm>
-            <a:off x="3867912" y="2164479"/>
+            <a:off x="4402606" y="2187726"/>
             <a:ext cx="795528" cy="265176"/>
           </a:xfrm>
           <a:prstGeom prst="rect">
@@ -21752,7 +21752,7 @@
         </p:nvSpPr>
         <p:spPr>
           <a:xfrm>
-            <a:off x="3867912" y="2164479"/>
+            <a:off x="4402606" y="2187726"/>
             <a:ext cx="795528" cy="265176"/>
           </a:xfrm>
           <a:prstGeom prst="rect">
@@ -21791,7 +21791,7 @@
         </p:nvSpPr>
         <p:spPr>
           <a:xfrm>
-            <a:off x="4690872" y="2164479"/>
+            <a:off x="5225566" y="2187726"/>
             <a:ext cx="722376" cy="265176"/>
           </a:xfrm>
           <a:prstGeom prst="rect">
@@ -21818,7 +21818,7 @@
         </p:nvSpPr>
         <p:spPr>
           <a:xfrm>
-            <a:off x="4690872" y="2164479"/>
+            <a:off x="5225566" y="2187726"/>
             <a:ext cx="722376" cy="265176"/>
           </a:xfrm>
           <a:prstGeom prst="rect">
@@ -21857,7 +21857,7 @@
         </p:nvSpPr>
         <p:spPr>
           <a:xfrm>
-            <a:off x="5440680" y="2164479"/>
+            <a:off x="5975374" y="2187726"/>
             <a:ext cx="722376" cy="265176"/>
           </a:xfrm>
           <a:prstGeom prst="rect">
@@ -21884,7 +21884,7 @@
         </p:nvSpPr>
         <p:spPr>
           <a:xfrm>
-            <a:off x="5440680" y="2164479"/>
+            <a:off x="5975374" y="2187726"/>
             <a:ext cx="722376" cy="265176"/>
           </a:xfrm>
           <a:prstGeom prst="rect">
@@ -21923,7 +21923,7 @@
         </p:nvSpPr>
         <p:spPr>
           <a:xfrm>
-            <a:off x="6190488" y="2164479"/>
+            <a:off x="6725182" y="2187726"/>
             <a:ext cx="777240" cy="265176"/>
           </a:xfrm>
           <a:prstGeom prst="rect">
@@ -21950,7 +21950,7 @@
         </p:nvSpPr>
         <p:spPr>
           <a:xfrm>
-            <a:off x="6190488" y="2164479"/>
+            <a:off x="6725182" y="2187726"/>
             <a:ext cx="777240" cy="265176"/>
           </a:xfrm>
           <a:prstGeom prst="rect">
@@ -21989,7 +21989,7 @@
         </p:nvSpPr>
         <p:spPr>
           <a:xfrm>
-            <a:off x="6995160" y="2164479"/>
+            <a:off x="7529854" y="2187726"/>
             <a:ext cx="777240" cy="265176"/>
           </a:xfrm>
           <a:prstGeom prst="rect">
@@ -22016,7 +22016,7 @@
         </p:nvSpPr>
         <p:spPr>
           <a:xfrm>
-            <a:off x="6995160" y="2164479"/>
+            <a:off x="7529854" y="2187726"/>
             <a:ext cx="777240" cy="265176"/>
           </a:xfrm>
           <a:prstGeom prst="rect">

</xml_diff>